<commit_message>
fix: tighten PPTX compatibility acceptance
</commit_message>
<xml_diff>
--- a/tests/fixtures/compatibility/text-theme-wide.pptx
+++ b/tests/fixtures/compatibility/text-theme-wide.pptx
@@ -1047,11 +1047,50 @@
                 <a:solidFill>
                   <a:srgbClr val="334155"/>
                 </a:solidFill>
-                <a:latin typeface="Arial" pitchFamily="34" charset="0"/>
-                <a:ea typeface="Arial" pitchFamily="34" charset="-122"/>
-                <a:cs typeface="Arial" pitchFamily="34" charset="-120"/>
+                <a:latin typeface="Times New Roman" pitchFamily="34" charset="0"/>
+                <a:ea typeface="Times New Roman" pitchFamily="34" charset="-122"/>
+                <a:cs typeface="Times New Roman" pitchFamily="34" charset="-120"/>
               </a:rPr>
-              <a:t>Theme-aware headline · regular · italic</a:t>
+              <a:t>Times New Roman sample</a:t>
+            </a:r>
+            <a:endParaRPr lang="en-US" sz="1800" dirty="0"/>
+          </a:p>
+        </p:txBody>
+      </p:sp>
+      <p:sp>
+        <p:nvSpPr>
+          <p:cNvPr id="5" name="Text 3"/>
+          <p:cNvSpPr/>
+          <p:nvPr/>
+        </p:nvSpPr>
+        <p:spPr>
+          <a:xfrm>
+            <a:off x="731520" y="3520440"/>
+            <a:ext cx="7315200" cy="457200"/>
+          </a:xfrm>
+          <a:prstGeom prst="rect">
+            <a:avLst/>
+          </a:prstGeom>
+          <a:noFill/>
+          <a:ln/>
+        </p:spPr>
+        <p:txBody>
+          <a:bodyPr wrap="square" lIns="0" tIns="0" rIns="0" bIns="0" rtlCol="0" anchor="ctr"/>
+          <a:lstStyle/>
+          <a:p>
+            <a:pPr indent="0" marL="0">
+              <a:buNone/>
+            </a:pPr>
+            <a:r>
+              <a:rPr lang="en-US" sz="1800" dirty="0">
+                <a:solidFill>
+                  <a:srgbClr val="334155"/>
+                </a:solidFill>
+                <a:latin typeface="Definitely Missing Font" pitchFamily="34" charset="0"/>
+                <a:ea typeface="Definitely Missing Font" pitchFamily="34" charset="-122"/>
+                <a:cs typeface="Definitely Missing Font" pitchFamily="34" charset="-120"/>
+              </a:rPr>
+              <a:t>Missing font fallback sample</a:t>
             </a:r>
             <a:endParaRPr lang="en-US" sz="1800" dirty="0"/>
           </a:p>

</xml_diff>